<commit_message>
md and docx change
</commit_message>
<xml_diff>
--- a/Դիպլոմ_Պրեզենտացիա.pptx
+++ b/Դիպլոմ_Պրեզենտացիա.pptx
@@ -3651,7 +3651,7 @@
           <a:p>
             <a:pPr algn="just"/>
             <a:r>
-              <a:rPr lang="hy-AM" sz="2000" dirty="0">
+              <a:rPr lang="hy-AM" dirty="0">
                 <a:solidFill>
                   <a:schemeClr val="bg1"/>
                 </a:solidFill>
@@ -3659,7 +3659,7 @@
               <a:t>Հայաստանի շուկայում չկա հասկանալի և հարմար դիզայնով ավտոմեքենաների առքուվաճառքի պլատֆորմ, շուկայի մոնոպոլիստը </a:t>
             </a:r>
             <a:r>
-              <a:rPr lang="en-US" sz="2000" dirty="0">
+              <a:rPr lang="en-US" dirty="0">
                 <a:solidFill>
                   <a:schemeClr val="bg1"/>
                 </a:solidFill>
@@ -3667,7 +3667,7 @@
               <a:t>Auto.am</a:t>
             </a:r>
             <a:r>
-              <a:rPr lang="hy-AM" sz="2000" dirty="0">
+              <a:rPr lang="hy-AM" dirty="0">
                 <a:solidFill>
                   <a:schemeClr val="bg1"/>
                 </a:solidFill>
@@ -3675,7 +3675,7 @@
               <a:t>-ն է, որը չի տարբերվում սովորական լիսթինգ կայքերից </a:t>
             </a:r>
             <a:r>
-              <a:rPr lang="en-US" sz="2000" dirty="0">
+              <a:rPr lang="en-US" dirty="0">
                 <a:solidFill>
                   <a:schemeClr val="bg1"/>
                 </a:solidFill>
@@ -3683,7 +3683,7 @@
               <a:t>(</a:t>
             </a:r>
             <a:r>
-              <a:rPr lang="hy-AM" sz="2000" dirty="0">
+              <a:rPr lang="hy-AM" dirty="0">
                 <a:solidFill>
                   <a:schemeClr val="bg1"/>
                 </a:solidFill>
@@ -3691,7 +3691,7 @@
               <a:t>Օրինակ՝ </a:t>
             </a:r>
             <a:r>
-              <a:rPr lang="en-US" sz="2000" dirty="0">
+              <a:rPr lang="en-US" dirty="0">
                 <a:solidFill>
                   <a:schemeClr val="bg1"/>
                 </a:solidFill>
@@ -3699,7 +3699,7 @@
               <a:t>List.am)</a:t>
             </a:r>
             <a:r>
-              <a:rPr lang="hy-AM" sz="2000" dirty="0">
+              <a:rPr lang="hy-AM" dirty="0">
                 <a:solidFill>
                   <a:schemeClr val="bg1"/>
                 </a:solidFill>
@@ -3707,7 +3707,7 @@
               <a:t>։</a:t>
             </a:r>
             <a:r>
-              <a:rPr lang="en-US" sz="2000" dirty="0">
+              <a:rPr lang="en-US" dirty="0">
                 <a:solidFill>
                   <a:schemeClr val="bg1"/>
                 </a:solidFill>
@@ -3715,14 +3715,14 @@
               <a:t> </a:t>
             </a:r>
             <a:r>
-              <a:rPr lang="hy-AM" sz="2000" dirty="0">
+              <a:rPr lang="hy-AM" dirty="0">
                 <a:solidFill>
                   <a:schemeClr val="bg1"/>
                 </a:solidFill>
               </a:rPr>
               <a:t>Չունի հարմար, գեղեցիկ և հասկանալի դիզայն, չունի գնահատման համակարգ, որով կարելի է տարբերակել զերծարարներին, տեխնիկապես հնացած է և չունի վերֆիկացիայի համակարգ։ </a:t>
             </a:r>
-            <a:endParaRPr lang="en-US" sz="2000" dirty="0">
+            <a:endParaRPr lang="en-US" dirty="0">
               <a:solidFill>
                 <a:schemeClr val="bg1"/>
               </a:solidFill>
@@ -3752,8 +3752,8 @@
         </p:blipFill>
         <p:spPr>
           <a:xfrm>
-            <a:off x="2601380" y="2586555"/>
-            <a:ext cx="6989240" cy="3995220"/>
+            <a:off x="2601380" y="2819400"/>
+            <a:ext cx="6989240" cy="3762374"/>
           </a:xfrm>
           <a:prstGeom prst="roundRect">
             <a:avLst>

</xml_diff>